<commit_message>
Branded readouts, story and site owner deck: group lead model, no vote
Align the logo versions with the site owner breakout slide: a group lead
who facilitates and builds, tests renamed to quality, time saved and PM
approval rules, a feedback coordinator instead of a pilot owner, and a
90-second summary at the Summit Debrief in place of the Monday-morning
vote. Previous branded files kept in ws2/archive.

Co-Authored-By: Claude Opus 5.5 <noreply@anthropic.com>
Claude-Session: https://claude.ai/code/session_01Q2YJhmzjoSxdfw8ZKRnAPH
</commit_message>
<xml_diff>
--- a/ws2/files/branded/WS2_Session_Overview.pptx
+++ b/ws2/files/branded/WS2_Session_Overview.pptx
@@ -107,7 +107,7 @@
   <p:extLst>
     <p:ext uri="{521415D9-36F7-43E2-AB2F-B90AF26B5E84}">
       <p14:sectionLst xmlns:p14="http://schemas.microsoft.com/office/powerpoint/2010/main">
-        <p14:section name="Session overview" id="{48d933c2-5d37-82fc-8820-7a9c0910705c}">
+        <p14:section name="Session overview" id="{8b11613b-3e7d-2b56-5512-abf58d6bb63a}">
           <p14:sldIdLst>
             <p14:sldId id="256"/>
           </p14:sldIdLst>
@@ -519,9 +519,9 @@
               <a:t>Walk through the session left to right.
 1. Introduction (10 min, plenary): why the PM role is changing, and the goal of the session: define your work around AI. Participants already know their room, so they go straight in afterwards.
 2. AI use cases (2 x 15 min, plenary): two real use cases show what an agent can take over and what it took to get there.
-3. Breakout (60 min, rooms C1 to C6): each room works one KESTREL case, designs and tests one agent, and leaves with a Pilot Pack and a 90-second debrief card. Facilitator and Builder per room; the room readout is read aloud at minute 0.
-4. Wrap-up (20 min, plenary): the Summit Debrief. Each room reads its card, everyone votes on which pilot they would implement on Monday morning, three awards, pilot owners named.
-Before: rooms are allocated in the invitation on 29 Oct and pre-work is done by 3 Nov. On the day, site owners provide rooms, screens, network, the capture link with a paper fallback, and the live scoreboard. After: pilot owners by 12 Nov, 30-day readout in early December.</a:t>
+3. Breakout (60 min, rooms C1 to C6): each room works one KESTREL case. The group lead runs the room and builds the agent in Agent Builder; the team checks and records the results. Every room leaves with a Pilot Pack and a 90-second summary.
+4. Wrap-up (20 min, plenary): the Summit Debrief. Each room shares its 90-second summary: what it will try next week, the time it could save and what it still has to fix. Feedback coordinators are named.
+Before: rooms are allocated in the invitation on 29 Oct and pre-work is done by 3 Nov; every group lead has Agent Builder activated. On the day, site owners provide a space per room near the plenary, a laptop, screen, network and tool access, and the case, sample data and Pilot Pack. After: every room tries its agent the week after the summit, the feedback coordinators collect the results, and the 30-day readout follows in early December.</a:t>
             </a:r>
             <a:endParaRPr lang="en-US" dirty="0"/>
           </a:p>
@@ -1212,7 +1212,7 @@
                   <a:schemeClr val="bg2"/>
                 </a:solidFill>
               </a:rPr>
-              <a:t>120 minutes, the same in every region. One outcome: pilots people want to run on Monday.</a:t>
+              <a:t>120 minutes, the same in every region. One outcome: an agent every room tries the week after.</a:t>
             </a:r>
             <a:endParaRPr lang="en-US" sz="1400" dirty="0"/>
           </a:p>
@@ -2227,7 +2227,7 @@
                   <a:schemeClr val="accent1"/>
                 </a:solidFill>
               </a:rPr>
-              <a:t>60 min · rooms C1–C6 · facilitator + Builder</a:t>
+              <a:t>60 min · rooms C1–C6 · group lead + team</a:t>
             </a:r>
             <a:endParaRPr lang="en-US" sz="1100" dirty="0"/>
           </a:p>
@@ -2651,7 +2651,7 @@
                   <a:schemeClr val="bg1"/>
                 </a:solidFill>
               </a:rPr>
-              <a:t>Output: Pilot Pack + 90-second debrief card</a:t>
+              <a:t>Output: Pilot Pack + 90-second summary</a:t>
             </a:r>
             <a:endParaRPr lang="en-US" sz="1400" dirty="0"/>
           </a:p>
@@ -2844,7 +2844,7 @@
                   <a:schemeClr val="bg1"/>
                 </a:solidFill>
               </a:rPr>
-              <a:t>Summit Debrief, 90 s per room</a:t>
+              <a:t>Summit Debrief: 90 s per room</a:t>
             </a:r>
             <a:endParaRPr lang="en-US" sz="1400" dirty="0"/>
           </a:p>
@@ -2862,7 +2862,7 @@
                   <a:schemeClr val="bg1"/>
                 </a:solidFill>
               </a:rPr>
-              <a:t>Vote: which pilot on Monday morning?</a:t>
+              <a:t>What each room tries next week</a:t>
             </a:r>
             <a:endParaRPr lang="en-US" sz="1400" dirty="0"/>
           </a:p>
@@ -2880,7 +2880,7 @@
                   <a:schemeClr val="bg1"/>
                 </a:solidFill>
               </a:rPr>
-              <a:t>Three awards, pilot owners named</a:t>
+              <a:t>Feedback coordinators named</a:t>
             </a:r>
             <a:endParaRPr lang="en-US" sz="1400" dirty="0"/>
           </a:p>
@@ -3014,7 +3014,7 @@
                   <a:schemeClr val="bg1"/>
                 </a:solidFill>
               </a:rPr>
-              <a:t>One Builder per room with Agent Builder</a:t>
+              <a:t>Group lead per room with Agent Builder</a:t>
             </a:r>
             <a:endParaRPr lang="en-US" sz="1400" dirty="0"/>
           </a:p>
@@ -3112,7 +3112,7 @@
                   <a:schemeClr val="bg1"/>
                 </a:solidFill>
               </a:rPr>
-              <a:t>A room, screen and network per breakout</a:t>
+              <a:t>A space per room near the plenary</a:t>
             </a:r>
             <a:endParaRPr lang="en-US" sz="1400" dirty="0"/>
           </a:p>
@@ -3130,7 +3130,7 @@
                   <a:schemeClr val="bg1"/>
                 </a:solidFill>
               </a:rPr>
-              <a:t>Capture link plus paper fallback</a:t>
+              <a:t>Laptop, screen, network, tool access</a:t>
             </a:r>
             <a:endParaRPr lang="en-US" sz="1400" dirty="0"/>
           </a:p>
@@ -3148,7 +3148,7 @@
                   <a:schemeClr val="bg1"/>
                 </a:solidFill>
               </a:rPr>
-              <a:t>Live scoreboard on the plenary screen</a:t>
+              <a:t>Case, sample data and Pilot Pack</a:t>
             </a:r>
             <a:endParaRPr lang="en-US" sz="1400" dirty="0"/>
           </a:p>
@@ -3246,7 +3246,7 @@
                   <a:schemeClr val="bg1"/>
                 </a:solidFill>
               </a:rPr>
-              <a:t>Pilot owners confirmed by 12 Nov</a:t>
+              <a:t>Each room tries its agent the next week</a:t>
             </a:r>
             <a:endParaRPr lang="en-US" sz="1400" dirty="0"/>
           </a:p>
@@ -3264,7 +3264,25 @@
                   <a:schemeClr val="bg1"/>
                 </a:solidFill>
               </a:rPr>
-              <a:t>30-day pilot readout in early December</a:t>
+              <a:t>Feedback coordinators collect results</a:t>
+            </a:r>
+            <a:endParaRPr lang="en-US" sz="1400" dirty="0"/>
+          </a:p>
+          <a:p>
+            <a:pPr marL="177800" indent="-177800">
+              <a:spcAft>
+                <a:spcPts val="200"/>
+              </a:spcAft>
+              <a:buSzPct val="100000"/>
+              <a:buChar char="•"/>
+            </a:pPr>
+            <a:r>
+              <a:rPr lang="en-US" sz="1400" dirty="0">
+                <a:solidFill>
+                  <a:schemeClr val="bg1"/>
+                </a:solidFill>
+              </a:rPr>
+              <a:t>30-day readout in early December</a:t>
             </a:r>
             <a:endParaRPr lang="en-US" sz="1400" dirty="0"/>
           </a:p>

</xml_diff>